<commit_message>
TP5 : refonte slides 3-4 (3 transformations de preparation)
</commit_message>
<xml_diff>
--- a/TP5/presentation/Lab5_Anomalies_DBSCAN.pptx
+++ b/TP5/presentation/Lab5_Anomalies_DBSCAN.pptx
@@ -6271,6 +6271,23 @@
             </a:r>
             <a:endParaRPr lang="en-US" sz="1200" dirty="0"/>
           </a:p>
+          <a:p>
+            <a:pPr algn="ctr" indent="0" marL="0">
+              <a:buNone/>
+            </a:pPr>
+            <a:r>
+              <a:rPr lang="en-US" sz="1200" dirty="0">
+                <a:solidFill>
+                  <a:srgbClr val="5B6B7A"/>
+                </a:solidFill>
+                <a:latin typeface="Calibri" pitchFamily="34" charset="0"/>
+                <a:ea typeface="Calibri" pitchFamily="34" charset="-122"/>
+                <a:cs typeface="Calibri" pitchFamily="34" charset="-120"/>
+              </a:rPr>
+              <a:t>(filtrés depuis 19 516)</a:t>
+            </a:r>
+            <a:endParaRPr lang="en-US" sz="1200" dirty="0"/>
+          </a:p>
         </p:txBody>
       </p:sp>
       <p:sp>
@@ -6409,7 +6426,7 @@
                 <a:ea typeface="Calibri" pitchFamily="34" charset="-122"/>
                 <a:cs typeface="Calibri" pitchFamily="34" charset="-120"/>
               </a:rPr>
-              <a:t>(z-scores standardisés)</a:t>
+              <a:t>imposées par le sujet</a:t>
             </a:r>
             <a:endParaRPr lang="en-US" sz="1200" dirty="0"/>
           </a:p>
@@ -6977,7 +6994,7 @@
                 <a:ea typeface="Georgia" pitchFamily="34" charset="-122"/>
                 <a:cs typeface="Georgia" pitchFamily="34" charset="-120"/>
               </a:rPr>
-              <a:t>Données déjà préparées (z-scores standardisés)</a:t>
+              <a:t>Source — dataset projet ESB</a:t>
             </a:r>
             <a:endParaRPr lang="en-US" sz="1400" dirty="0"/>
           </a:p>
@@ -7016,7 +7033,7 @@
                 <a:ea typeface="Calibri" pitchFamily="34" charset="-122"/>
                 <a:cs typeface="Calibri" pitchFamily="34" charset="-120"/>
               </a:rPr>
-              <a:t>Les 3 variables sont centrées-réduites : moyenne = 0, écart-type = 1. </a:t>
+              <a:t>On part du même fichier brut que les autres TPs (Electric School Bus Initiative, 19 516 districts). </a:t>
             </a:r>
             <a:pPr indent="0" marL="0">
               <a:buNone/>
@@ -7030,7 +7047,7 @@
                 <a:ea typeface="Calibri" pitchFamily="34" charset="-122"/>
                 <a:cs typeface="Calibri" pitchFamily="34" charset="-120"/>
               </a:rPr>
-              <a:t>Cette standardisation est indispensable pour DBSCAN, qui repose sur des distances euclidiennes : sans elle, la variable au plus grand écart-type écraserait les autres.</a:t>
+              <a:t>Pour le TP5, on ne garde que les 3 variables imposées par le sujet et on filtre les districts avec données complètes → 12 837 lignes, ensuite standardisées.</a:t>
             </a:r>
             <a:endParaRPr lang="en-US" sz="1200" dirty="0"/>
           </a:p>
@@ -7227,14 +7244,53 @@
       </p:sp>
       <p:sp>
         <p:nvSpPr>
-          <p:cNvPr id="4" name="Shape 2"/>
-          <p:cNvSpPr/>
-          <p:nvPr/>
-        </p:nvSpPr>
-        <p:spPr>
-          <a:xfrm>
-            <a:off x="457200" y="1188720"/>
-            <a:ext cx="11247120" cy="2286000"/>
+          <p:cNvPr id="4" name="Text 2"/>
+          <p:cNvSpPr/>
+          <p:nvPr/>
+        </p:nvSpPr>
+        <p:spPr>
+          <a:xfrm>
+            <a:off x="731520" y="1005840"/>
+            <a:ext cx="10972800" cy="457200"/>
+          </a:xfrm>
+          <a:prstGeom prst="rect">
+            <a:avLst/>
+          </a:prstGeom>
+          <a:noFill/>
+          <a:ln/>
+        </p:spPr>
+        <p:txBody>
+          <a:bodyPr wrap="square" lIns="0" tIns="0" rIns="0" bIns="0" rtlCol="0" anchor="t"/>
+          <a:lstStyle/>
+          <a:p>
+            <a:pPr indent="0" marL="0">
+              <a:buNone/>
+            </a:pPr>
+            <a:r>
+              <a:rPr lang="en-US" sz="1250" i="1" dirty="0">
+                <a:solidFill>
+                  <a:srgbClr val="5B6B7A"/>
+                </a:solidFill>
+                <a:latin typeface="Calibri" pitchFamily="34" charset="0"/>
+                <a:ea typeface="Calibri" pitchFamily="34" charset="-122"/>
+                <a:cs typeface="Calibri" pitchFamily="34" charset="-120"/>
+              </a:rPr>
+              <a:t>Trois transformations appliquées en amont par l'équipe pour passer du dataset brut au fichier d'entraînement anomalies.csv.</a:t>
+            </a:r>
+            <a:endParaRPr lang="en-US" sz="1250" dirty="0"/>
+          </a:p>
+        </p:txBody>
+      </p:sp>
+      <p:sp>
+        <p:nvSpPr>
+          <p:cNvPr id="5" name="Shape 3"/>
+          <p:cNvSpPr/>
+          <p:nvPr/>
+        </p:nvSpPr>
+        <p:spPr>
+          <a:xfrm>
+            <a:off x="457200" y="1600200"/>
+            <a:ext cx="11247120" cy="914400"/>
           </a:xfrm>
           <a:prstGeom prst="rect">
             <a:avLst/>
@@ -7254,14 +7310,14 @@
       </p:sp>
       <p:sp>
         <p:nvSpPr>
-          <p:cNvPr id="5" name="Shape 3"/>
-          <p:cNvSpPr/>
-          <p:nvPr/>
-        </p:nvSpPr>
-        <p:spPr>
-          <a:xfrm>
-            <a:off x="457200" y="1188720"/>
-            <a:ext cx="109728" cy="2286000"/>
+          <p:cNvPr id="6" name="Shape 4"/>
+          <p:cNvSpPr/>
+          <p:nvPr/>
+        </p:nvSpPr>
+        <p:spPr>
+          <a:xfrm>
+            <a:off x="457200" y="1600200"/>
+            <a:ext cx="109728" cy="914400"/>
           </a:xfrm>
           <a:prstGeom prst="rect">
             <a:avLst/>
@@ -7274,14 +7330,34 @@
       </p:sp>
       <p:sp>
         <p:nvSpPr>
-          <p:cNvPr id="6" name="Text 4"/>
-          <p:cNvSpPr/>
-          <p:nvPr/>
-        </p:nvSpPr>
-        <p:spPr>
-          <a:xfrm>
-            <a:off x="731520" y="1325880"/>
-            <a:ext cx="10789920" cy="365760"/>
+          <p:cNvPr id="7" name="Shape 5"/>
+          <p:cNvSpPr/>
+          <p:nvPr/>
+        </p:nvSpPr>
+        <p:spPr>
+          <a:xfrm>
+            <a:off x="777240" y="1801368"/>
+            <a:ext cx="502920" cy="502920"/>
+          </a:xfrm>
+          <a:prstGeom prst="ellipse">
+            <a:avLst/>
+          </a:prstGeom>
+          <a:solidFill>
+            <a:srgbClr val="2E6E9E"/>
+          </a:solidFill>
+          <a:ln/>
+        </p:spPr>
+      </p:sp>
+      <p:sp>
+        <p:nvSpPr>
+          <p:cNvPr id="8" name="Text 6"/>
+          <p:cNvSpPr/>
+          <p:nvPr/>
+        </p:nvSpPr>
+        <p:spPr>
+          <a:xfrm>
+            <a:off x="777240" y="1801368"/>
+            <a:ext cx="502920" cy="502920"/>
           </a:xfrm>
           <a:prstGeom prst="rect">
             <a:avLst/>
@@ -7293,34 +7369,34 @@
           <a:bodyPr wrap="square" lIns="0" tIns="0" rIns="0" bIns="0" rtlCol="0" anchor="ctr"/>
           <a:lstStyle/>
           <a:p>
-            <a:pPr indent="0" marL="0">
-              <a:buNone/>
-            </a:pPr>
-            <a:r>
-              <a:rPr lang="en-US" sz="1600" b="1" dirty="0">
-                <a:solidFill>
-                  <a:srgbClr val="1B3A5B"/>
+            <a:pPr algn="ctr" indent="0" marL="0">
+              <a:buNone/>
+            </a:pPr>
+            <a:r>
+              <a:rPr lang="en-US" sz="1800" b="1" dirty="0">
+                <a:solidFill>
+                  <a:srgbClr val="FFFFFF"/>
                 </a:solidFill>
                 <a:latin typeface="Georgia" pitchFamily="34" charset="0"/>
                 <a:ea typeface="Georgia" pitchFamily="34" charset="-122"/>
                 <a:cs typeface="Georgia" pitchFamily="34" charset="-120"/>
               </a:rPr>
-              <a:t>Étape unique : standardisation (déjà appliquée en amont)</a:t>
-            </a:r>
-            <a:endParaRPr lang="en-US" sz="1600" dirty="0"/>
-          </a:p>
-        </p:txBody>
-      </p:sp>
-      <p:sp>
-        <p:nvSpPr>
-          <p:cNvPr id="7" name="Text 5"/>
-          <p:cNvSpPr/>
-          <p:nvPr/>
-        </p:nvSpPr>
-        <p:spPr>
-          <a:xfrm>
-            <a:off x="731520" y="1783080"/>
-            <a:ext cx="10789920" cy="1645920"/>
+              <a:t>1</a:t>
+            </a:r>
+            <a:endParaRPr lang="en-US" sz="1800" dirty="0"/>
+          </a:p>
+        </p:txBody>
+      </p:sp>
+      <p:sp>
+        <p:nvSpPr>
+          <p:cNvPr id="9" name="Text 7"/>
+          <p:cNvSpPr/>
+          <p:nvPr/>
+        </p:nvSpPr>
+        <p:spPr>
+          <a:xfrm>
+            <a:off x="1417320" y="1709928"/>
+            <a:ext cx="4114800" cy="365760"/>
           </a:xfrm>
           <a:prstGeom prst="rect">
             <a:avLst/>
@@ -7329,6 +7405,45 @@
           <a:ln/>
         </p:spPr>
         <p:txBody>
+          <a:bodyPr wrap="square" lIns="0" tIns="0" rIns="0" bIns="0" rtlCol="0" anchor="ctr"/>
+          <a:lstStyle/>
+          <a:p>
+            <a:pPr indent="0" marL="0">
+              <a:buNone/>
+            </a:pPr>
+            <a:r>
+              <a:rPr lang="en-US" sz="1500" b="1" dirty="0">
+                <a:solidFill>
+                  <a:srgbClr val="1B3A5B"/>
+                </a:solidFill>
+                <a:latin typeface="Georgia" pitchFamily="34" charset="0"/>
+                <a:ea typeface="Georgia" pitchFamily="34" charset="-122"/>
+                <a:cs typeface="Georgia" pitchFamily="34" charset="-120"/>
+              </a:rPr>
+              <a:t>Sélection des variables</a:t>
+            </a:r>
+            <a:endParaRPr lang="en-US" sz="1500" dirty="0"/>
+          </a:p>
+        </p:txBody>
+      </p:sp>
+      <p:sp>
+        <p:nvSpPr>
+          <p:cNvPr id="10" name="Text 8"/>
+          <p:cNvSpPr/>
+          <p:nvPr/>
+        </p:nvSpPr>
+        <p:spPr>
+          <a:xfrm>
+            <a:off x="1417320" y="2057400"/>
+            <a:ext cx="10058400" cy="457200"/>
+          </a:xfrm>
+          <a:prstGeom prst="rect">
+            <a:avLst/>
+          </a:prstGeom>
+          <a:noFill/>
+          <a:ln/>
+        </p:spPr>
+        <p:txBody>
           <a:bodyPr wrap="square" lIns="0" tIns="0" rIns="0" bIns="0" rtlCol="0" anchor="t"/>
           <a:lstStyle/>
           <a:p>
@@ -7336,7 +7451,7 @@
               <a:buNone/>
             </a:pPr>
             <a:r>
-              <a:rPr lang="en-US" sz="1300" dirty="0">
+              <a:rPr lang="en-US" sz="1200" dirty="0">
                 <a:solidFill>
                   <a:srgbClr val="1E2A36"/>
                 </a:solidFill>
@@ -7344,132 +7459,28 @@
                 <a:ea typeface="Calibri" pitchFamily="34" charset="-122"/>
                 <a:cs typeface="Calibri" pitchFamily="34" charset="-120"/>
               </a:rPr>
-              <a:t>Le jeu de données </a:t>
-            </a:r>
-            <a:pPr indent="0" marL="0">
-              <a:buNone/>
-            </a:pPr>
-            <a:r>
-              <a:rPr lang="en-US" sz="1300" b="1" dirty="0">
-                <a:solidFill>
-                  <a:srgbClr val="1E2A36"/>
-                </a:solidFill>
-                <a:latin typeface="Consolas" pitchFamily="34" charset="0"/>
-                <a:ea typeface="Consolas" pitchFamily="34" charset="-122"/>
-                <a:cs typeface="Consolas" pitchFamily="34" charset="-120"/>
-              </a:rPr>
-              <a:t>anomalies.csv</a:t>
-            </a:r>
-            <a:pPr indent="0" marL="0">
-              <a:buNone/>
-            </a:pPr>
-            <a:r>
-              <a:rPr lang="en-US" sz="1300" dirty="0">
-                <a:solidFill>
-                  <a:srgbClr val="1E2A36"/>
-                </a:solidFill>
-                <a:latin typeface="Calibri" pitchFamily="34" charset="0"/>
-                <a:ea typeface="Calibri" pitchFamily="34" charset="-122"/>
-                <a:cs typeface="Calibri" pitchFamily="34" charset="-120"/>
-              </a:rPr>
-              <a:t> est livré </a:t>
-            </a:r>
-            <a:pPr indent="0" marL="0">
-              <a:buNone/>
-            </a:pPr>
-            <a:r>
-              <a:rPr lang="en-US" sz="1300" b="1" dirty="0">
-                <a:solidFill>
-                  <a:srgbClr val="1C9A8E"/>
-                </a:solidFill>
-                <a:latin typeface="Calibri" pitchFamily="34" charset="0"/>
-                <a:ea typeface="Calibri" pitchFamily="34" charset="-122"/>
-                <a:cs typeface="Calibri" pitchFamily="34" charset="-120"/>
-              </a:rPr>
-              <a:t>déjà standardisé</a:t>
-            </a:r>
-            <a:pPr indent="0" marL="0">
-              <a:buNone/>
-            </a:pPr>
-            <a:r>
-              <a:rPr lang="en-US" sz="1300" dirty="0">
-                <a:solidFill>
-                  <a:srgbClr val="1E2A36"/>
-                </a:solidFill>
-                <a:latin typeface="Calibri" pitchFamily="34" charset="0"/>
-                <a:ea typeface="Calibri" pitchFamily="34" charset="-122"/>
-                <a:cs typeface="Calibri" pitchFamily="34" charset="-120"/>
-              </a:rPr>
-              <a:t> : pour chaque variable, on a soustrait la moyenne et divisé par l'écart-type. Résultat : moyenne 0, écart-type 1 pour chacune des 3 variables.</a:t>
-            </a:r>
-            <a:endParaRPr lang="en-US" sz="1300" dirty="0"/>
-          </a:p>
-          <a:p>
-            <a:pPr indent="0" marL="0">
-              <a:buNone/>
-            </a:pPr>
-            <a:r>
-              <a:rPr lang="en-US" sz="800" dirty="0">
-                <a:solidFill>
-                  <a:srgbClr val="1E2A36"/>
-                </a:solidFill>
-                <a:latin typeface="Calibri" pitchFamily="34" charset="0"/>
-                <a:ea typeface="Calibri" pitchFamily="34" charset="-122"/>
-                <a:cs typeface="Calibri" pitchFamily="34" charset="-120"/>
-              </a:rPr>
-              <a:t> </a:t>
-            </a:r>
-            <a:endParaRPr lang="en-US" sz="1300" dirty="0"/>
-          </a:p>
-          <a:p>
-            <a:pPr indent="0" marL="0">
-              <a:buNone/>
-            </a:pPr>
-            <a:r>
-              <a:rPr lang="en-US" sz="1300" b="1" dirty="0">
-                <a:solidFill>
-                  <a:srgbClr val="1B3A5B"/>
-                </a:solidFill>
-                <a:latin typeface="Calibri" pitchFamily="34" charset="0"/>
-                <a:ea typeface="Calibri" pitchFamily="34" charset="-122"/>
-                <a:cs typeface="Calibri" pitchFamily="34" charset="-120"/>
-              </a:rPr>
-              <a:t>Pourquoi c'est indispensable pour DBSCAN : </a:t>
-            </a:r>
-            <a:pPr indent="0" marL="0">
-              <a:buNone/>
-            </a:pPr>
-            <a:r>
-              <a:rPr lang="en-US" sz="1300" dirty="0">
-                <a:solidFill>
-                  <a:srgbClr val="1E2A36"/>
-                </a:solidFill>
-                <a:latin typeface="Calibri" pitchFamily="34" charset="0"/>
-                <a:ea typeface="Calibri" pitchFamily="34" charset="-122"/>
-                <a:cs typeface="Calibri" pitchFamily="34" charset="-120"/>
-              </a:rPr>
-              <a:t>l'algorithme calcule des distances euclidiennes entre points. Sans standardisation, la variable à plus grand écart-type (le revenu, en milliers) écraserait totalement les autres (en pourcentages). Aucune autre transformation n'est nécessaire — le jeu est prêt pour DBSCAN.</a:t>
-            </a:r>
-            <a:endParaRPr lang="en-US" sz="1300" dirty="0"/>
-          </a:p>
-        </p:txBody>
-      </p:sp>
-      <p:sp>
-        <p:nvSpPr>
-          <p:cNvPr id="8" name="Shape 6"/>
-          <p:cNvSpPr/>
-          <p:nvPr/>
-        </p:nvSpPr>
-        <p:spPr>
-          <a:xfrm>
-            <a:off x="457200" y="3657600"/>
-            <a:ext cx="11247120" cy="1463040"/>
+              <a:t>On garde uniquement les 3 variables imposées par le sujet : revenu médian, % pauvreté, % flotte électrique.</a:t>
+            </a:r>
+            <a:endParaRPr lang="en-US" sz="1200" dirty="0"/>
+          </a:p>
+        </p:txBody>
+      </p:sp>
+      <p:sp>
+        <p:nvSpPr>
+          <p:cNvPr id="11" name="Shape 9"/>
+          <p:cNvSpPr/>
+          <p:nvPr/>
+        </p:nvSpPr>
+        <p:spPr>
+          <a:xfrm>
+            <a:off x="457200" y="2651760"/>
+            <a:ext cx="11247120" cy="914400"/>
           </a:xfrm>
           <a:prstGeom prst="rect">
             <a:avLst/>
           </a:prstGeom>
           <a:solidFill>
-            <a:srgbClr val="1B3A5B"/>
+            <a:srgbClr val="FFFFFF"/>
           </a:solidFill>
           <a:ln/>
           <a:effectLst>
@@ -7483,14 +7494,54 @@
       </p:sp>
       <p:sp>
         <p:nvSpPr>
-          <p:cNvPr id="9" name="Text 7"/>
-          <p:cNvSpPr/>
-          <p:nvPr/>
-        </p:nvSpPr>
-        <p:spPr>
-          <a:xfrm>
-            <a:off x="685800" y="3749040"/>
-            <a:ext cx="10789920" cy="365760"/>
+          <p:cNvPr id="12" name="Shape 10"/>
+          <p:cNvSpPr/>
+          <p:nvPr/>
+        </p:nvSpPr>
+        <p:spPr>
+          <a:xfrm>
+            <a:off x="457200" y="2651760"/>
+            <a:ext cx="109728" cy="914400"/>
+          </a:xfrm>
+          <a:prstGeom prst="rect">
+            <a:avLst/>
+          </a:prstGeom>
+          <a:solidFill>
+            <a:srgbClr val="147A70"/>
+          </a:solidFill>
+          <a:ln/>
+        </p:spPr>
+      </p:sp>
+      <p:sp>
+        <p:nvSpPr>
+          <p:cNvPr id="13" name="Shape 11"/>
+          <p:cNvSpPr/>
+          <p:nvPr/>
+        </p:nvSpPr>
+        <p:spPr>
+          <a:xfrm>
+            <a:off x="777240" y="2852928"/>
+            <a:ext cx="502920" cy="502920"/>
+          </a:xfrm>
+          <a:prstGeom prst="ellipse">
+            <a:avLst/>
+          </a:prstGeom>
+          <a:solidFill>
+            <a:srgbClr val="147A70"/>
+          </a:solidFill>
+          <a:ln/>
+        </p:spPr>
+      </p:sp>
+      <p:sp>
+        <p:nvSpPr>
+          <p:cNvPr id="14" name="Text 12"/>
+          <p:cNvSpPr/>
+          <p:nvPr/>
+        </p:nvSpPr>
+        <p:spPr>
+          <a:xfrm>
+            <a:off x="777240" y="2852928"/>
+            <a:ext cx="502920" cy="502920"/>
           </a:xfrm>
           <a:prstGeom prst="rect">
             <a:avLst/>
@@ -7502,34 +7553,34 @@
           <a:bodyPr wrap="square" lIns="0" tIns="0" rIns="0" bIns="0" rtlCol="0" anchor="ctr"/>
           <a:lstStyle/>
           <a:p>
-            <a:pPr indent="0" marL="0">
-              <a:buNone/>
-            </a:pPr>
-            <a:r>
-              <a:rPr lang="en-US" sz="1400" b="1" dirty="0">
-                <a:solidFill>
-                  <a:srgbClr val="1C9A8E"/>
+            <a:pPr algn="ctr" indent="0" marL="0">
+              <a:buNone/>
+            </a:pPr>
+            <a:r>
+              <a:rPr lang="en-US" sz="1800" b="1" dirty="0">
+                <a:solidFill>
+                  <a:srgbClr val="FFFFFF"/>
                 </a:solidFill>
                 <a:latin typeface="Georgia" pitchFamily="34" charset="0"/>
                 <a:ea typeface="Georgia" pitchFamily="34" charset="-122"/>
                 <a:cs typeface="Georgia" pitchFamily="34" charset="-120"/>
               </a:rPr>
-              <a:t>Note sur les valeurs extrêmes</a:t>
-            </a:r>
-            <a:endParaRPr lang="en-US" sz="1400" dirty="0"/>
-          </a:p>
-        </p:txBody>
-      </p:sp>
-      <p:sp>
-        <p:nvSpPr>
-          <p:cNvPr id="10" name="Text 8"/>
-          <p:cNvSpPr/>
-          <p:nvPr/>
-        </p:nvSpPr>
-        <p:spPr>
-          <a:xfrm>
-            <a:off x="685800" y="4114800"/>
-            <a:ext cx="10789920" cy="960120"/>
+              <a:t>2</a:t>
+            </a:r>
+            <a:endParaRPr lang="en-US" sz="1800" dirty="0"/>
+          </a:p>
+        </p:txBody>
+      </p:sp>
+      <p:sp>
+        <p:nvSpPr>
+          <p:cNvPr id="15" name="Text 13"/>
+          <p:cNvSpPr/>
+          <p:nvPr/>
+        </p:nvSpPr>
+        <p:spPr>
+          <a:xfrm>
+            <a:off x="1417320" y="2761488"/>
+            <a:ext cx="4114800" cy="365760"/>
           </a:xfrm>
           <a:prstGeom prst="rect">
             <a:avLst/>
@@ -7538,6 +7589,45 @@
           <a:ln/>
         </p:spPr>
         <p:txBody>
+          <a:bodyPr wrap="square" lIns="0" tIns="0" rIns="0" bIns="0" rtlCol="0" anchor="ctr"/>
+          <a:lstStyle/>
+          <a:p>
+            <a:pPr indent="0" marL="0">
+              <a:buNone/>
+            </a:pPr>
+            <a:r>
+              <a:rPr lang="en-US" sz="1500" b="1" dirty="0">
+                <a:solidFill>
+                  <a:srgbClr val="1B3A5B"/>
+                </a:solidFill>
+                <a:latin typeface="Georgia" pitchFamily="34" charset="0"/>
+                <a:ea typeface="Georgia" pitchFamily="34" charset="-122"/>
+                <a:cs typeface="Georgia" pitchFamily="34" charset="-120"/>
+              </a:rPr>
+              <a:t>Filtrage des districts</a:t>
+            </a:r>
+            <a:endParaRPr lang="en-US" sz="1500" dirty="0"/>
+          </a:p>
+        </p:txBody>
+      </p:sp>
+      <p:sp>
+        <p:nvSpPr>
+          <p:cNvPr id="16" name="Text 14"/>
+          <p:cNvSpPr/>
+          <p:nvPr/>
+        </p:nvSpPr>
+        <p:spPr>
+          <a:xfrm>
+            <a:off x="1417320" y="3108960"/>
+            <a:ext cx="10058400" cy="457200"/>
+          </a:xfrm>
+          <a:prstGeom prst="rect">
+            <a:avLst/>
+          </a:prstGeom>
+          <a:noFill/>
+          <a:ln/>
+        </p:spPr>
+        <p:txBody>
           <a:bodyPr wrap="square" lIns="0" tIns="0" rIns="0" bIns="0" rtlCol="0" anchor="t"/>
           <a:lstStyle/>
           <a:p>
@@ -7547,138 +7637,338 @@
             <a:r>
               <a:rPr lang="en-US" sz="1200" dirty="0">
                 <a:solidFill>
-                  <a:srgbClr val="CADCFC"/>
+                  <a:srgbClr val="1E2A36"/>
                 </a:solidFill>
                 <a:latin typeface="Calibri" pitchFamily="34" charset="0"/>
                 <a:ea typeface="Calibri" pitchFamily="34" charset="-122"/>
                 <a:cs typeface="Calibri" pitchFamily="34" charset="-120"/>
               </a:rPr>
-              <a:t>Le « % flotte électrique » contient quelques valeurs très élevées — jusqu'à +89 σ. </a:t>
-            </a:r>
+              <a:t>On ne conserve que les districts ayant les 3 variables renseignées. Résultat : 19 516 → 12 837 districts.</a:t>
+            </a:r>
+            <a:endParaRPr lang="en-US" sz="1200" dirty="0"/>
+          </a:p>
+        </p:txBody>
+      </p:sp>
+      <p:sp>
+        <p:nvSpPr>
+          <p:cNvPr id="17" name="Shape 15"/>
+          <p:cNvSpPr/>
+          <p:nvPr/>
+        </p:nvSpPr>
+        <p:spPr>
+          <a:xfrm>
+            <a:off x="457200" y="3703320"/>
+            <a:ext cx="11247120" cy="914400"/>
+          </a:xfrm>
+          <a:prstGeom prst="rect">
+            <a:avLst/>
+          </a:prstGeom>
+          <a:solidFill>
+            <a:srgbClr val="FFFFFF"/>
+          </a:solidFill>
+          <a:ln/>
+          <a:effectLst>
+            <a:outerShdw sx="100000" sy="100000" kx="0" ky="0" algn="bl" rotWithShape="0" blurRad="76200" dist="25400" dir="8100000">
+              <a:srgbClr val="000000">
+                <a:alpha val="12000"/>
+              </a:srgbClr>
+            </a:outerShdw>
+          </a:effectLst>
+        </p:spPr>
+      </p:sp>
+      <p:sp>
+        <p:nvSpPr>
+          <p:cNvPr id="18" name="Shape 16"/>
+          <p:cNvSpPr/>
+          <p:nvPr/>
+        </p:nvSpPr>
+        <p:spPr>
+          <a:xfrm>
+            <a:off x="457200" y="3703320"/>
+            <a:ext cx="109728" cy="914400"/>
+          </a:xfrm>
+          <a:prstGeom prst="rect">
+            <a:avLst/>
+          </a:prstGeom>
+          <a:solidFill>
+            <a:srgbClr val="C8872E"/>
+          </a:solidFill>
+          <a:ln/>
+        </p:spPr>
+      </p:sp>
+      <p:sp>
+        <p:nvSpPr>
+          <p:cNvPr id="19" name="Shape 17"/>
+          <p:cNvSpPr/>
+          <p:nvPr/>
+        </p:nvSpPr>
+        <p:spPr>
+          <a:xfrm>
+            <a:off x="777240" y="3904488"/>
+            <a:ext cx="502920" cy="502920"/>
+          </a:xfrm>
+          <a:prstGeom prst="ellipse">
+            <a:avLst/>
+          </a:prstGeom>
+          <a:solidFill>
+            <a:srgbClr val="C8872E"/>
+          </a:solidFill>
+          <a:ln/>
+        </p:spPr>
+      </p:sp>
+      <p:sp>
+        <p:nvSpPr>
+          <p:cNvPr id="20" name="Text 18"/>
+          <p:cNvSpPr/>
+          <p:nvPr/>
+        </p:nvSpPr>
+        <p:spPr>
+          <a:xfrm>
+            <a:off x="777240" y="3904488"/>
+            <a:ext cx="502920" cy="502920"/>
+          </a:xfrm>
+          <a:prstGeom prst="rect">
+            <a:avLst/>
+          </a:prstGeom>
+          <a:noFill/>
+          <a:ln/>
+        </p:spPr>
+        <p:txBody>
+          <a:bodyPr wrap="square" lIns="0" tIns="0" rIns="0" bIns="0" rtlCol="0" anchor="ctr"/>
+          <a:lstStyle/>
+          <a:p>
+            <a:pPr algn="ctr" indent="0" marL="0">
+              <a:buNone/>
+            </a:pPr>
+            <a:r>
+              <a:rPr lang="en-US" sz="1800" b="1" dirty="0">
+                <a:solidFill>
+                  <a:srgbClr val="FFFFFF"/>
+                </a:solidFill>
+                <a:latin typeface="Georgia" pitchFamily="34" charset="0"/>
+                <a:ea typeface="Georgia" pitchFamily="34" charset="-122"/>
+                <a:cs typeface="Georgia" pitchFamily="34" charset="-120"/>
+              </a:rPr>
+              <a:t>3</a:t>
+            </a:r>
+            <a:endParaRPr lang="en-US" sz="1800" dirty="0"/>
+          </a:p>
+        </p:txBody>
+      </p:sp>
+      <p:sp>
+        <p:nvSpPr>
+          <p:cNvPr id="21" name="Text 19"/>
+          <p:cNvSpPr/>
+          <p:nvPr/>
+        </p:nvSpPr>
+        <p:spPr>
+          <a:xfrm>
+            <a:off x="1417320" y="3813048"/>
+            <a:ext cx="4114800" cy="365760"/>
+          </a:xfrm>
+          <a:prstGeom prst="rect">
+            <a:avLst/>
+          </a:prstGeom>
+          <a:noFill/>
+          <a:ln/>
+        </p:spPr>
+        <p:txBody>
+          <a:bodyPr wrap="square" lIns="0" tIns="0" rIns="0" bIns="0" rtlCol="0" anchor="ctr"/>
+          <a:lstStyle/>
+          <a:p>
             <a:pPr indent="0" marL="0">
               <a:buNone/>
             </a:pPr>
             <a:r>
+              <a:rPr lang="en-US" sz="1500" b="1" dirty="0">
+                <a:solidFill>
+                  <a:srgbClr val="1B3A5B"/>
+                </a:solidFill>
+                <a:latin typeface="Georgia" pitchFamily="34" charset="0"/>
+                <a:ea typeface="Georgia" pitchFamily="34" charset="-122"/>
+                <a:cs typeface="Georgia" pitchFamily="34" charset="-120"/>
+              </a:rPr>
+              <a:t>Standardisation z-score</a:t>
+            </a:r>
+            <a:endParaRPr lang="en-US" sz="1500" dirty="0"/>
+          </a:p>
+        </p:txBody>
+      </p:sp>
+      <p:sp>
+        <p:nvSpPr>
+          <p:cNvPr id="22" name="Text 20"/>
+          <p:cNvSpPr/>
+          <p:nvPr/>
+        </p:nvSpPr>
+        <p:spPr>
+          <a:xfrm>
+            <a:off x="1417320" y="4160520"/>
+            <a:ext cx="10058400" cy="457200"/>
+          </a:xfrm>
+          <a:prstGeom prst="rect">
+            <a:avLst/>
+          </a:prstGeom>
+          <a:noFill/>
+          <a:ln/>
+        </p:spPr>
+        <p:txBody>
+          <a:bodyPr wrap="square" lIns="0" tIns="0" rIns="0" bIns="0" rtlCol="0" anchor="t"/>
+          <a:lstStyle/>
+          <a:p>
+            <a:pPr indent="0" marL="0">
+              <a:buNone/>
+            </a:pPr>
+            <a:r>
               <a:rPr lang="en-US" sz="1200" dirty="0">
                 <a:solidFill>
-                  <a:srgbClr val="CADCFC"/>
+                  <a:srgbClr val="1E2A36"/>
                 </a:solidFill>
                 <a:latin typeface="Calibri" pitchFamily="34" charset="0"/>
                 <a:ea typeface="Calibri" pitchFamily="34" charset="-122"/>
                 <a:cs typeface="Calibri" pitchFamily="34" charset="-120"/>
               </a:rPr>
-              <a:t>Ce sont des erreurs de saisie dans la source (pourcentages &gt; 100 %). </a:t>
-            </a:r>
+              <a:t>Pour chaque variable : (x − moyenne) ÷ écart-type. Résultat final : moyenne 0, écart-type 1.</a:t>
+            </a:r>
+            <a:endParaRPr lang="en-US" sz="1200" dirty="0"/>
+          </a:p>
+        </p:txBody>
+      </p:sp>
+      <p:sp>
+        <p:nvSpPr>
+          <p:cNvPr id="23" name="Shape 21"/>
+          <p:cNvSpPr/>
+          <p:nvPr/>
+        </p:nvSpPr>
+        <p:spPr>
+          <a:xfrm>
+            <a:off x="457200" y="4846320"/>
+            <a:ext cx="11247120" cy="1097280"/>
+          </a:xfrm>
+          <a:prstGeom prst="rect">
+            <a:avLst/>
+          </a:prstGeom>
+          <a:solidFill>
+            <a:srgbClr val="1B3A5B"/>
+          </a:solidFill>
+          <a:ln/>
+          <a:effectLst>
+            <a:outerShdw sx="100000" sy="100000" kx="0" ky="0" algn="bl" rotWithShape="0" blurRad="76200" dist="25400" dir="8100000">
+              <a:srgbClr val="000000">
+                <a:alpha val="12000"/>
+              </a:srgbClr>
+            </a:outerShdw>
+          </a:effectLst>
+        </p:spPr>
+      </p:sp>
+      <p:sp>
+        <p:nvSpPr>
+          <p:cNvPr id="24" name="Text 22"/>
+          <p:cNvSpPr/>
+          <p:nvPr/>
+        </p:nvSpPr>
+        <p:spPr>
+          <a:xfrm>
+            <a:off x="685800" y="4937760"/>
+            <a:ext cx="10789920" cy="365760"/>
+          </a:xfrm>
+          <a:prstGeom prst="rect">
+            <a:avLst/>
+          </a:prstGeom>
+          <a:noFill/>
+          <a:ln/>
+        </p:spPr>
+        <p:txBody>
+          <a:bodyPr wrap="square" lIns="0" tIns="0" rIns="0" bIns="0" rtlCol="0" anchor="ctr"/>
+          <a:lstStyle/>
+          <a:p>
             <a:pPr indent="0" marL="0">
               <a:buNone/>
             </a:pPr>
             <a:r>
-              <a:rPr lang="en-US" sz="1200" i="1" dirty="0">
-                <a:solidFill>
-                  <a:srgbClr val="FFFFFF"/>
+              <a:rPr lang="en-US" sz="1300" b="1" dirty="0">
+                <a:solidFill>
+                  <a:srgbClr val="1C9A8E"/>
+                </a:solidFill>
+                <a:latin typeface="Georgia" pitchFamily="34" charset="0"/>
+                <a:ea typeface="Georgia" pitchFamily="34" charset="-122"/>
+                <a:cs typeface="Georgia" pitchFamily="34" charset="-120"/>
+              </a:rPr>
+              <a:t>Pourquoi la standardisation est indispensable pour DBSCAN</a:t>
+            </a:r>
+            <a:endParaRPr lang="en-US" sz="1300" dirty="0"/>
+          </a:p>
+        </p:txBody>
+      </p:sp>
+      <p:sp>
+        <p:nvSpPr>
+          <p:cNvPr id="25" name="Text 23"/>
+          <p:cNvSpPr/>
+          <p:nvPr/>
+        </p:nvSpPr>
+        <p:spPr>
+          <a:xfrm>
+            <a:off x="685800" y="5285232"/>
+            <a:ext cx="10789920" cy="640080"/>
+          </a:xfrm>
+          <a:prstGeom prst="rect">
+            <a:avLst/>
+          </a:prstGeom>
+          <a:noFill/>
+          <a:ln/>
+        </p:spPr>
+        <p:txBody>
+          <a:bodyPr wrap="square" lIns="0" tIns="0" rIns="0" bIns="0" rtlCol="0" anchor="t"/>
+          <a:lstStyle/>
+          <a:p>
+            <a:pPr indent="0" marL="0">
+              <a:buNone/>
+            </a:pPr>
+            <a:r>
+              <a:rPr lang="en-US" sz="1100" dirty="0">
+                <a:solidFill>
+                  <a:srgbClr val="CADCFC"/>
                 </a:solidFill>
                 <a:latin typeface="Calibri" pitchFamily="34" charset="0"/>
                 <a:ea typeface="Calibri" pitchFamily="34" charset="-122"/>
                 <a:cs typeface="Calibri" pitchFamily="34" charset="-120"/>
               </a:rPr>
-              <a:t>Choix : on ne les supprime pas — DBSCAN va naturellement les détecter comme anomalies, c'est précisément ce qu'on cherche.</a:t>
-            </a:r>
-            <a:endParaRPr lang="en-US" sz="1200" dirty="0"/>
-          </a:p>
-        </p:txBody>
-      </p:sp>
-      <p:sp>
-        <p:nvSpPr>
-          <p:cNvPr id="11" name="Shape 9"/>
-          <p:cNvSpPr/>
-          <p:nvPr/>
-        </p:nvSpPr>
-        <p:spPr>
-          <a:xfrm>
-            <a:off x="457200" y="5303520"/>
-            <a:ext cx="11247120" cy="640080"/>
-          </a:xfrm>
-          <a:prstGeom prst="roundRect">
-            <a:avLst>
-              <a:gd name="adj" fmla="val 8571"/>
-            </a:avLst>
-          </a:prstGeom>
-          <a:solidFill>
-            <a:srgbClr val="E3EEF5"/>
-          </a:solidFill>
-          <a:ln/>
-        </p:spPr>
-      </p:sp>
-      <p:sp>
-        <p:nvSpPr>
-          <p:cNvPr id="12" name="Text 10"/>
-          <p:cNvSpPr/>
-          <p:nvPr/>
-        </p:nvSpPr>
-        <p:spPr>
-          <a:xfrm>
-            <a:off x="731520" y="5303520"/>
-            <a:ext cx="10789920" cy="640080"/>
-          </a:xfrm>
-          <a:prstGeom prst="rect">
-            <a:avLst/>
-          </a:prstGeom>
-          <a:noFill/>
-          <a:ln/>
-        </p:spPr>
-        <p:txBody>
-          <a:bodyPr wrap="square" lIns="0" tIns="0" rIns="0" bIns="0" rtlCol="0" anchor="ctr"/>
-          <a:lstStyle/>
-          <a:p>
+              <a:t>DBSCAN repose sur des distances euclidiennes. Sans standardisation, le revenu (en milliers de dollars) écraserait totalement le % de pauvreté et le % flotte électrique (en pourcentages). </a:t>
+            </a:r>
             <a:pPr indent="0" marL="0">
               <a:buNone/>
             </a:pPr>
             <a:r>
-              <a:rPr lang="en-US" sz="1250" b="1" dirty="0">
-                <a:solidFill>
-                  <a:srgbClr val="1B3A5B"/>
+              <a:rPr lang="en-US" sz="1100" b="1" dirty="0">
+                <a:solidFill>
+                  <a:srgbClr val="FFFFFF"/>
                 </a:solidFill>
                 <a:latin typeface="Calibri" pitchFamily="34" charset="0"/>
                 <a:ea typeface="Calibri" pitchFamily="34" charset="-122"/>
                 <a:cs typeface="Calibri" pitchFamily="34" charset="-120"/>
               </a:rPr>
-              <a:t>Livrable :  </a:t>
+              <a:t>Valeurs extrêmes laissées en place : </a:t>
             </a:r>
             <a:pPr indent="0" marL="0">
               <a:buNone/>
             </a:pPr>
             <a:r>
-              <a:rPr lang="en-US" sz="1250" b="1" dirty="0">
-                <a:solidFill>
-                  <a:srgbClr val="000000"/>
-                </a:solidFill>
-                <a:latin typeface="Consolas" pitchFamily="34" charset="0"/>
-                <a:ea typeface="Consolas" pitchFamily="34" charset="-122"/>
-                <a:cs typeface="Consolas" pitchFamily="34" charset="-120"/>
-              </a:rPr>
-              <a:t>anomalies.csv</a:t>
-            </a:r>
-            <a:pPr indent="0" marL="0">
-              <a:buNone/>
-            </a:pPr>
-            <a:r>
-              <a:rPr lang="en-US" sz="1250" dirty="0">
-                <a:solidFill>
-                  <a:srgbClr val="1E2A36"/>
+              <a:rPr lang="en-US" sz="1100" i="1" dirty="0">
+                <a:solidFill>
+                  <a:srgbClr val="CADCFC"/>
                 </a:solidFill>
                 <a:latin typeface="Calibri" pitchFamily="34" charset="0"/>
                 <a:ea typeface="Calibri" pitchFamily="34" charset="-122"/>
                 <a:cs typeface="Calibri" pitchFamily="34" charset="-120"/>
               </a:rPr>
-              <a:t>  (12 837 districts × 3 variables) — fichier d'entraînement demandé par le sujet.</a:t>
-            </a:r>
-            <a:endParaRPr lang="en-US" sz="1250" dirty="0"/>
-          </a:p>
-        </p:txBody>
-      </p:sp>
-      <p:sp>
-        <p:nvSpPr>
-          <p:cNvPr id="13" name="Shape 11"/>
+              <a:t>le % flotte électrique contient des erreurs de saisie (&gt; 100 %, jusqu'à +89 σ). On ne les supprime pas — DBSCAN va précisément les détecter comme anomalies.</a:t>
+            </a:r>
+            <a:endParaRPr lang="en-US" sz="1100" dirty="0"/>
+          </a:p>
+        </p:txBody>
+      </p:sp>
+      <p:sp>
+        <p:nvSpPr>
+          <p:cNvPr id="26" name="Shape 24"/>
           <p:cNvSpPr/>
           <p:nvPr/>
         </p:nvSpPr>
@@ -7698,7 +7988,7 @@
       </p:sp>
       <p:sp>
         <p:nvSpPr>
-          <p:cNvPr id="14" name="Text 12"/>
+          <p:cNvPr id="27" name="Text 25"/>
           <p:cNvSpPr/>
           <p:nvPr/>
         </p:nvSpPr>
@@ -7737,7 +8027,7 @@
       </p:sp>
       <p:sp>
         <p:nvSpPr>
-          <p:cNvPr id="15" name="Text 13"/>
+          <p:cNvPr id="28" name="Text 26"/>
           <p:cNvSpPr/>
           <p:nvPr/>
         </p:nvSpPr>

</xml_diff>